<commit_message>
Part 1 Problem 3 - Facade pattern reinforcement in SMTP/IMAP/NNTP
</commit_message>
<xml_diff>
--- a/3.5-Software-Architecture-Final-Project.pptx
+++ b/3.5-Software-Architecture-Final-Project.pptx
@@ -21,6 +21,8 @@
     <p:sldId id="269" r:id="rId20"/>
     <p:sldId id="270" r:id="rId21"/>
     <p:sldId id="271" r:id="rId22"/>
+    <p:sldId id="275" r:id="rId26"/>
+    <p:sldId id="276" r:id="rId27"/>
     <p:sldId id="272" r:id="rId23"/>
     <p:sldId id="273" r:id="rId24"/>
     <p:sldId id="274" r:id="rId25"/>
@@ -8015,7 +8017,7 @@
                   <a:srgbClr val="1F3D6B"/>
                 </a:solidFill>
               </a:rPr>
-              <a:t>Facade Boundary Blurry (non-FTP)</a:t>
+              <a:t>Facade Boundary Blurry (non-FTP)  ✅ DONE</a:t>
             </a:r>
           </a:p>
         </p:txBody>
@@ -8049,7 +8051,7 @@
                   <a:srgbClr val="333333"/>
                 </a:solidFill>
               </a:rPr>
-              <a:t>SMTPClient, IMAPClient, NNTPClient mix raw commands with business logic. Enforce: base = raw commands; client = high-level API.</a:t>
+              <a:t>Implemented as Improvement 3 — see preceding two slides. Base classes (SMTP/IMAP/NNTP) now own all raw protocol I/O; client classes are pure facades.</a:t>
             </a:r>
           </a:p>
         </p:txBody>
@@ -11864,6 +11866,996 @@
                 </a:solidFill>
               </a:rPr>
               <a:t>IP address &amp; subnet math utilities</a:t>
+            </a:r>
+          </a:p>
+        </p:txBody>
+      </p:sp>
+    </p:spTree>
+  </p:cSld>
+  <p:clrMapOvr>
+    <a:masterClrMapping/>
+  </p:clrMapOvr>
+</p:sld>
+</file>
+
+<file path=ppt/slides/slide20.xml><?xml version="1.0" encoding="utf-8"?>
+<p:sld xmlns:a="http://schemas.openxmlformats.org/drawingml/2006/main" xmlns:p="http://schemas.openxmlformats.org/presentationml/2006/main" xmlns:r="http://schemas.openxmlformats.org/officeDocument/2006/relationships">
+  <p:cSld>
+    <p:spTree>
+      <p:nvGrpSpPr>
+        <p:cNvPr id="1" name=""/>
+        <p:cNvGrpSpPr/>
+        <p:nvPr/>
+      </p:nvGrpSpPr>
+      <p:grpSpPr/>
+      <p:sp>
+        <p:nvSpPr>
+          <p:cNvPr id="2" name="Rectangle 1"/>
+          <p:cNvSpPr/>
+          <p:nvPr/>
+        </p:nvSpPr>
+        <p:spPr>
+          <a:xfrm>
+            <a:off x="0" y="0"/>
+            <a:ext cx="12188952" cy="1097280"/>
+          </a:xfrm>
+          <a:prstGeom prst="rect">
+            <a:avLst/>
+          </a:prstGeom>
+          <a:solidFill>
+            <a:srgbClr val="1F3D6B"/>
+          </a:solidFill>
+          <a:ln>
+            <a:noFill/>
+          </a:ln>
+        </p:spPr>
+        <p:style>
+          <a:lnRef idx="1">
+            <a:schemeClr val="accent1"/>
+          </a:lnRef>
+          <a:fillRef idx="3">
+            <a:schemeClr val="accent1"/>
+          </a:fillRef>
+          <a:effectRef idx="2">
+            <a:schemeClr val="accent1"/>
+          </a:effectRef>
+          <a:fontRef idx="minor">
+            <a:schemeClr val="lt1"/>
+          </a:fontRef>
+        </p:style>
+        <p:txBody>
+          <a:bodyPr rtlCol="0" anchor="ctr"/>
+          <a:lstStyle/>
+          <a:p>
+            <a:pPr algn="ctr"/>
+          </a:p>
+        </p:txBody>
+      </p:sp>
+      <p:sp>
+        <p:nvSpPr>
+          <p:cNvPr id="3" name="TextBox 2"/>
+          <p:cNvSpPr txBox="1"/>
+          <p:nvPr/>
+        </p:nvSpPr>
+        <p:spPr>
+          <a:xfrm>
+            <a:off x="274320" y="91440"/>
+            <a:ext cx="11430000" cy="640080"/>
+          </a:xfrm>
+          <a:prstGeom prst="rect">
+            <a:avLst/>
+          </a:prstGeom>
+          <a:noFill/>
+        </p:spPr>
+        <p:txBody>
+          <a:bodyPr wrap="square">
+            <a:spAutoFit/>
+          </a:bodyPr>
+          <a:lstStyle/>
+          <a:p>
+            <a:pPr algn="l"/>
+            <a:r>
+              <a:rPr sz="2800" b="1">
+                <a:solidFill>
+                  <a:srgbClr val="FFFFFF"/>
+                </a:solidFill>
+              </a:rPr>
+              <a:t>Improvement 3 — Facade Pattern</a:t>
+            </a:r>
+          </a:p>
+        </p:txBody>
+      </p:sp>
+      <p:sp>
+        <p:nvSpPr>
+          <p:cNvPr id="4" name="TextBox 3"/>
+          <p:cNvSpPr txBox="1"/>
+          <p:nvPr/>
+        </p:nvSpPr>
+        <p:spPr>
+          <a:xfrm>
+            <a:off x="274320" y="685800"/>
+            <a:ext cx="11430000" cy="365760"/>
+          </a:xfrm>
+          <a:prstGeom prst="rect">
+            <a:avLst/>
+          </a:prstGeom>
+          <a:noFill/>
+        </p:spPr>
+        <p:txBody>
+          <a:bodyPr wrap="square">
+            <a:spAutoFit/>
+          </a:bodyPr>
+          <a:lstStyle/>
+          <a:p>
+            <a:pPr algn="l"/>
+            <a:r>
+              <a:rPr sz="1300" b="0">
+                <a:solidFill>
+                  <a:srgbClr val="BBCCEE"/>
+                </a:solidFill>
+              </a:rPr>
+              <a:t>Why this pattern · Why not alternatives</a:t>
+            </a:r>
+          </a:p>
+        </p:txBody>
+      </p:sp>
+      <p:sp>
+        <p:nvSpPr>
+          <p:cNvPr id="5" name="Rectangle 4"/>
+          <p:cNvSpPr/>
+          <p:nvPr/>
+        </p:nvSpPr>
+        <p:spPr>
+          <a:xfrm>
+            <a:off x="274320" y="1234440"/>
+            <a:ext cx="5303520" cy="2651760"/>
+          </a:xfrm>
+          <a:prstGeom prst="rect">
+            <a:avLst/>
+          </a:prstGeom>
+          <a:solidFill>
+            <a:srgbClr val="DAE8FC"/>
+          </a:solidFill>
+          <a:ln w="9525">
+            <a:solidFill>
+              <a:srgbClr val="6C8EBF"/>
+            </a:solidFill>
+          </a:ln>
+        </p:spPr>
+        <p:style>
+          <a:lnRef idx="1">
+            <a:schemeClr val="accent1"/>
+          </a:lnRef>
+          <a:fillRef idx="3">
+            <a:schemeClr val="accent1"/>
+          </a:fillRef>
+          <a:effectRef idx="2">
+            <a:schemeClr val="accent1"/>
+          </a:effectRef>
+          <a:fontRef idx="minor">
+            <a:schemeClr val="lt1"/>
+          </a:fontRef>
+        </p:style>
+        <p:txBody>
+          <a:bodyPr rtlCol="0" anchor="ctr"/>
+          <a:lstStyle/>
+          <a:p>
+            <a:pPr algn="ctr"/>
+          </a:p>
+        </p:txBody>
+      </p:sp>
+      <p:sp>
+        <p:nvSpPr>
+          <p:cNvPr id="6" name="TextBox 5"/>
+          <p:cNvSpPr txBox="1"/>
+          <p:nvPr/>
+        </p:nvSpPr>
+        <p:spPr>
+          <a:xfrm>
+            <a:off x="411480" y="1298448"/>
+            <a:ext cx="5029200" cy="320040"/>
+          </a:xfrm>
+          <a:prstGeom prst="rect">
+            <a:avLst/>
+          </a:prstGeom>
+          <a:noFill/>
+        </p:spPr>
+        <p:txBody>
+          <a:bodyPr wrap="square">
+            <a:spAutoFit/>
+          </a:bodyPr>
+          <a:lstStyle/>
+          <a:p>
+            <a:pPr algn="l"/>
+            <a:r>
+              <a:rPr sz="1400" b="1">
+                <a:solidFill>
+                  <a:srgbClr val="1F3D6B"/>
+                </a:solidFill>
+              </a:rPr>
+              <a:t>Why This Pattern</a:t>
+            </a:r>
+          </a:p>
+        </p:txBody>
+      </p:sp>
+      <p:sp>
+        <p:nvSpPr>
+          <p:cNvPr id="7" name="TextBox 6"/>
+          <p:cNvSpPr txBox="1"/>
+          <p:nvPr/>
+        </p:nvSpPr>
+        <p:spPr>
+          <a:xfrm>
+            <a:off x="411480" y="1664208"/>
+            <a:ext cx="5029200" cy="2103120"/>
+          </a:xfrm>
+          <a:prstGeom prst="rect">
+            <a:avLst/>
+          </a:prstGeom>
+          <a:noFill/>
+        </p:spPr>
+        <p:txBody>
+          <a:bodyPr wrap="square">
+            <a:spAutoFit/>
+          </a:bodyPr>
+          <a:lstStyle/>
+          <a:p>
+            <a:pPr algn="l"/>
+            <a:r>
+              <a:rPr sz="1200" b="0">
+                <a:solidFill>
+                  <a:srgbClr val="333333"/>
+                </a:solidFill>
+              </a:rPr>
+              <a:t>FTPClient already follows the Facade pattern
+cleanly: FTP exposes raw RFC 959 commands
+and FTPClient hides the wire-level details.
+SMTPClient, IMAPClient, and NNTPClient share
+the same two-tier name but blur the boundary:
+they reach into _writer / _reader_ directly
+and inspect raw reply codes themselves.
+Reinforcing the Facade aligns all four clients
+with FTPClient — base = raw protocol I/O,
+client = high-level orchestration only.</a:t>
+            </a:r>
+          </a:p>
+        </p:txBody>
+      </p:sp>
+      <p:sp>
+        <p:nvSpPr>
+          <p:cNvPr id="8" name="Rectangle 7"/>
+          <p:cNvSpPr/>
+          <p:nvPr/>
+        </p:nvSpPr>
+        <p:spPr>
+          <a:xfrm>
+            <a:off x="5852160" y="1234440"/>
+            <a:ext cx="6035040" cy="2651760"/>
+          </a:xfrm>
+          <a:prstGeom prst="rect">
+            <a:avLst/>
+          </a:prstGeom>
+          <a:solidFill>
+            <a:srgbClr val="FFF2CC"/>
+          </a:solidFill>
+          <a:ln w="9525">
+            <a:solidFill>
+              <a:srgbClr val="D79B00"/>
+            </a:solidFill>
+          </a:ln>
+        </p:spPr>
+        <p:style>
+          <a:lnRef idx="1">
+            <a:schemeClr val="accent1"/>
+          </a:lnRef>
+          <a:fillRef idx="3">
+            <a:schemeClr val="accent1"/>
+          </a:fillRef>
+          <a:effectRef idx="2">
+            <a:schemeClr val="accent1"/>
+          </a:effectRef>
+          <a:fontRef idx="minor">
+            <a:schemeClr val="lt1"/>
+          </a:fontRef>
+        </p:style>
+        <p:txBody>
+          <a:bodyPr rtlCol="0" anchor="ctr"/>
+          <a:lstStyle/>
+          <a:p>
+            <a:pPr algn="ctr"/>
+          </a:p>
+        </p:txBody>
+      </p:sp>
+      <p:sp>
+        <p:nvSpPr>
+          <p:cNvPr id="9" name="TextBox 8"/>
+          <p:cNvSpPr txBox="1"/>
+          <p:nvPr/>
+        </p:nvSpPr>
+        <p:spPr>
+          <a:xfrm>
+            <a:off x="5989320" y="1298448"/>
+            <a:ext cx="5760720" cy="320040"/>
+          </a:xfrm>
+          <a:prstGeom prst="rect">
+            <a:avLst/>
+          </a:prstGeom>
+          <a:noFill/>
+        </p:spPr>
+        <p:txBody>
+          <a:bodyPr wrap="square">
+            <a:spAutoFit/>
+          </a:bodyPr>
+          <a:lstStyle/>
+          <a:p>
+            <a:pPr algn="l"/>
+            <a:r>
+              <a:rPr sz="1400" b="1">
+                <a:solidFill>
+                  <a:srgbClr val="1F3D6B"/>
+                </a:solidFill>
+              </a:rPr>
+              <a:t>Why Not Other Patterns</a:t>
+            </a:r>
+          </a:p>
+        </p:txBody>
+      </p:sp>
+      <p:sp>
+        <p:nvSpPr>
+          <p:cNvPr id="10" name="TextBox 9"/>
+          <p:cNvSpPr txBox="1"/>
+          <p:nvPr/>
+        </p:nvSpPr>
+        <p:spPr>
+          <a:xfrm>
+            <a:off x="5989320" y="1664208"/>
+            <a:ext cx="5760720" cy="2103120"/>
+          </a:xfrm>
+          <a:prstGeom prst="rect">
+            <a:avLst/>
+          </a:prstGeom>
+          <a:noFill/>
+        </p:spPr>
+        <p:txBody>
+          <a:bodyPr wrap="square">
+            <a:spAutoFit/>
+          </a:bodyPr>
+          <a:lstStyle/>
+          <a:p>
+            <a:pPr algn="l"/>
+            <a:r>
+              <a:rPr sz="1200" b="0">
+                <a:solidFill>
+                  <a:srgbClr val="333333"/>
+                </a:solidFill>
+              </a:rPr>
+              <a:t>Adapter — assumes an interface mismatch;
+the two tiers already speak the same API.
+Mediator — assumes peer-to-peer routing;
+the relationship here is strictly hierarchical.
+Decorator — would force every existing
+subclass to be rewritten as composition,
+breaking source compatibility.
+Template Method — would invert control
+and assumes a shared algorithm that the
+three protocols do not share.
+Bridge — explicitly out of scope per the
+project plan; no real implementation variation.</a:t>
+            </a:r>
+          </a:p>
+        </p:txBody>
+      </p:sp>
+      <p:sp>
+        <p:nvSpPr>
+          <p:cNvPr id="11" name="Rectangle 10"/>
+          <p:cNvSpPr/>
+          <p:nvPr/>
+        </p:nvSpPr>
+        <p:spPr>
+          <a:xfrm>
+            <a:off x="274320" y="4069080"/>
+            <a:ext cx="11612880" cy="2377440"/>
+          </a:xfrm>
+          <a:prstGeom prst="rect">
+            <a:avLst/>
+          </a:prstGeom>
+          <a:solidFill>
+            <a:srgbClr val="EECCFF"/>
+          </a:solidFill>
+          <a:ln w="9525">
+            <a:solidFill>
+              <a:srgbClr val="9955BB"/>
+            </a:solidFill>
+          </a:ln>
+        </p:spPr>
+        <p:style>
+          <a:lnRef idx="1">
+            <a:schemeClr val="accent1"/>
+          </a:lnRef>
+          <a:fillRef idx="3">
+            <a:schemeClr val="accent1"/>
+          </a:fillRef>
+          <a:effectRef idx="2">
+            <a:schemeClr val="accent1"/>
+          </a:effectRef>
+          <a:fontRef idx="minor">
+            <a:schemeClr val="lt1"/>
+          </a:fontRef>
+        </p:style>
+        <p:txBody>
+          <a:bodyPr rtlCol="0" anchor="ctr"/>
+          <a:lstStyle/>
+          <a:p>
+            <a:pPr algn="ctr"/>
+          </a:p>
+        </p:txBody>
+      </p:sp>
+      <p:sp>
+        <p:nvSpPr>
+          <p:cNvPr id="12" name="TextBox 11"/>
+          <p:cNvSpPr txBox="1"/>
+          <p:nvPr/>
+        </p:nvSpPr>
+        <p:spPr>
+          <a:xfrm>
+            <a:off x="411480" y="4133087"/>
+            <a:ext cx="5486400" cy="320040"/>
+          </a:xfrm>
+          <a:prstGeom prst="rect">
+            <a:avLst/>
+          </a:prstGeom>
+          <a:noFill/>
+        </p:spPr>
+        <p:txBody>
+          <a:bodyPr wrap="square">
+            <a:spAutoFit/>
+          </a:bodyPr>
+          <a:lstStyle/>
+          <a:p>
+            <a:pPr algn="l"/>
+            <a:r>
+              <a:rPr sz="1400" b="1">
+                <a:solidFill>
+                  <a:srgbClr val="1F3D6B"/>
+                </a:solidFill>
+              </a:rPr>
+              <a:t>Components Needed</a:t>
+            </a:r>
+          </a:p>
+        </p:txBody>
+      </p:sp>
+      <p:sp>
+        <p:nvSpPr>
+          <p:cNvPr id="13" name="TextBox 12"/>
+          <p:cNvSpPr txBox="1"/>
+          <p:nvPr/>
+        </p:nvSpPr>
+        <p:spPr>
+          <a:xfrm>
+            <a:off x="411480" y="4498848"/>
+            <a:ext cx="11064240" cy="1828800"/>
+          </a:xfrm>
+          <a:prstGeom prst="rect">
+            <a:avLst/>
+          </a:prstGeom>
+          <a:noFill/>
+        </p:spPr>
+        <p:txBody>
+          <a:bodyPr wrap="square">
+            <a:spAutoFit/>
+          </a:bodyPr>
+          <a:lstStyle/>
+          <a:p>
+            <a:pPr algn="l"/>
+            <a:r>
+              <a:rPr sz="1200" b="0">
+                <a:solidFill>
+                  <a:srgbClr val="333333"/>
+                </a:solidFill>
+              </a:rPr>
+              <a:t>SMTP — new protected Writer getDataWriter() owns DotTerminatedMessageWriter construction
+SMTPClient — sendMessageData() now calls getDataWriter() instead of accessing _writer directly
+IMAP — new public boolean appendWithData(args, message) handles the full two-step APPEND continuation+literal exchange
+IMAPClient — append() delegates the two-step exchange to appendWithData() and no longer inspects raw reply codes
+NNTP — new protected BufferedReader openMessageReader() and protected Writer getDataWriter() own dot-terminated stream wrapping
+NNTPClient — __retrieve(), postArticle(), forwardArticle() now use the new accessors instead of touching _reader_ / _writer_
+DotTerminatedMessageReader / DotTerminatedMessageWriter — unchanged; now constructed only inside the base classes</a:t>
+            </a:r>
+          </a:p>
+        </p:txBody>
+      </p:sp>
+    </p:spTree>
+  </p:cSld>
+  <p:clrMapOvr>
+    <a:masterClrMapping/>
+  </p:clrMapOvr>
+</p:sld>
+</file>
+
+<file path=ppt/slides/slide21.xml><?xml version="1.0" encoding="utf-8"?>
+<p:sld xmlns:a="http://schemas.openxmlformats.org/drawingml/2006/main" xmlns:p="http://schemas.openxmlformats.org/presentationml/2006/main" xmlns:r="http://schemas.openxmlformats.org/officeDocument/2006/relationships">
+  <p:cSld>
+    <p:spTree>
+      <p:nvGrpSpPr>
+        <p:cNvPr id="1" name=""/>
+        <p:cNvGrpSpPr/>
+        <p:nvPr/>
+      </p:nvGrpSpPr>
+      <p:grpSpPr/>
+      <p:sp>
+        <p:nvSpPr>
+          <p:cNvPr id="2" name="Rectangle 1"/>
+          <p:cNvSpPr/>
+          <p:nvPr/>
+        </p:nvSpPr>
+        <p:spPr>
+          <a:xfrm>
+            <a:off x="0" y="0"/>
+            <a:ext cx="12188952" cy="1097280"/>
+          </a:xfrm>
+          <a:prstGeom prst="rect">
+            <a:avLst/>
+          </a:prstGeom>
+          <a:solidFill>
+            <a:srgbClr val="1F3D6B"/>
+          </a:solidFill>
+          <a:ln>
+            <a:noFill/>
+          </a:ln>
+        </p:spPr>
+        <p:style>
+          <a:lnRef idx="1">
+            <a:schemeClr val="accent1"/>
+          </a:lnRef>
+          <a:fillRef idx="3">
+            <a:schemeClr val="accent1"/>
+          </a:fillRef>
+          <a:effectRef idx="2">
+            <a:schemeClr val="accent1"/>
+          </a:effectRef>
+          <a:fontRef idx="minor">
+            <a:schemeClr val="lt1"/>
+          </a:fontRef>
+        </p:style>
+        <p:txBody>
+          <a:bodyPr rtlCol="0" anchor="ctr"/>
+          <a:lstStyle/>
+          <a:p>
+            <a:pPr algn="ctr"/>
+          </a:p>
+        </p:txBody>
+      </p:sp>
+      <p:sp>
+        <p:nvSpPr>
+          <p:cNvPr id="3" name="TextBox 2"/>
+          <p:cNvSpPr txBox="1"/>
+          <p:nvPr/>
+        </p:nvSpPr>
+        <p:spPr>
+          <a:xfrm>
+            <a:off x="274320" y="91440"/>
+            <a:ext cx="11430000" cy="640080"/>
+          </a:xfrm>
+          <a:prstGeom prst="rect">
+            <a:avLst/>
+          </a:prstGeom>
+          <a:noFill/>
+        </p:spPr>
+        <p:txBody>
+          <a:bodyPr wrap="square">
+            <a:spAutoFit/>
+          </a:bodyPr>
+          <a:lstStyle/>
+          <a:p>
+            <a:pPr algn="l"/>
+            <a:r>
+              <a:rPr sz="2800" b="1">
+                <a:solidFill>
+                  <a:srgbClr val="FFFFFF"/>
+                </a:solidFill>
+              </a:rPr>
+              <a:t>Improvement 3 — Facade Pattern</a:t>
+            </a:r>
+          </a:p>
+        </p:txBody>
+      </p:sp>
+      <p:sp>
+        <p:nvSpPr>
+          <p:cNvPr id="4" name="TextBox 3"/>
+          <p:cNvSpPr txBox="1"/>
+          <p:nvPr/>
+        </p:nvSpPr>
+        <p:spPr>
+          <a:xfrm>
+            <a:off x="274320" y="685800"/>
+            <a:ext cx="11430000" cy="365760"/>
+          </a:xfrm>
+          <a:prstGeom prst="rect">
+            <a:avLst/>
+          </a:prstGeom>
+          <a:noFill/>
+        </p:spPr>
+        <p:txBody>
+          <a:bodyPr wrap="square">
+            <a:spAutoFit/>
+          </a:bodyPr>
+          <a:lstStyle/>
+          <a:p>
+            <a:pPr algn="l"/>
+            <a:r>
+              <a:rPr sz="1300" b="0">
+                <a:solidFill>
+                  <a:srgbClr val="BBCCEE"/>
+                </a:solidFill>
+              </a:rPr>
+              <a:t>Pros · Cons · Implementation</a:t>
+            </a:r>
+          </a:p>
+        </p:txBody>
+      </p:sp>
+      <p:sp>
+        <p:nvSpPr>
+          <p:cNvPr id="5" name="Rectangle 4"/>
+          <p:cNvSpPr/>
+          <p:nvPr/>
+        </p:nvSpPr>
+        <p:spPr>
+          <a:xfrm>
+            <a:off x="274320" y="1234440"/>
+            <a:ext cx="5303520" cy="2651760"/>
+          </a:xfrm>
+          <a:prstGeom prst="rect">
+            <a:avLst/>
+          </a:prstGeom>
+          <a:solidFill>
+            <a:srgbClr val="D5E8D4"/>
+          </a:solidFill>
+          <a:ln w="9525">
+            <a:solidFill>
+              <a:srgbClr val="2E7D32"/>
+            </a:solidFill>
+          </a:ln>
+        </p:spPr>
+        <p:style>
+          <a:lnRef idx="1">
+            <a:schemeClr val="accent1"/>
+          </a:lnRef>
+          <a:fillRef idx="3">
+            <a:schemeClr val="accent1"/>
+          </a:fillRef>
+          <a:effectRef idx="2">
+            <a:schemeClr val="accent1"/>
+          </a:effectRef>
+          <a:fontRef idx="minor">
+            <a:schemeClr val="lt1"/>
+          </a:fontRef>
+        </p:style>
+        <p:txBody>
+          <a:bodyPr rtlCol="0" anchor="ctr"/>
+          <a:lstStyle/>
+          <a:p>
+            <a:pPr algn="ctr"/>
+          </a:p>
+        </p:txBody>
+      </p:sp>
+      <p:sp>
+        <p:nvSpPr>
+          <p:cNvPr id="6" name="TextBox 5"/>
+          <p:cNvSpPr txBox="1"/>
+          <p:nvPr/>
+        </p:nvSpPr>
+        <p:spPr>
+          <a:xfrm>
+            <a:off x="411480" y="1298448"/>
+            <a:ext cx="5029200" cy="320040"/>
+          </a:xfrm>
+          <a:prstGeom prst="rect">
+            <a:avLst/>
+          </a:prstGeom>
+          <a:noFill/>
+        </p:spPr>
+        <p:txBody>
+          <a:bodyPr wrap="square">
+            <a:spAutoFit/>
+          </a:bodyPr>
+          <a:lstStyle/>
+          <a:p>
+            <a:pPr algn="l"/>
+            <a:r>
+              <a:rPr sz="1400" b="1">
+                <a:solidFill>
+                  <a:srgbClr val="1A6B2E"/>
+                </a:solidFill>
+              </a:rPr>
+              <a:t>Pros</a:t>
+            </a:r>
+          </a:p>
+        </p:txBody>
+      </p:sp>
+      <p:sp>
+        <p:nvSpPr>
+          <p:cNvPr id="7" name="TextBox 6"/>
+          <p:cNvSpPr txBox="1"/>
+          <p:nvPr/>
+        </p:nvSpPr>
+        <p:spPr>
+          <a:xfrm>
+            <a:off x="411480" y="1664208"/>
+            <a:ext cx="5029200" cy="2103120"/>
+          </a:xfrm>
+          <a:prstGeom prst="rect">
+            <a:avLst/>
+          </a:prstGeom>
+          <a:noFill/>
+        </p:spPr>
+        <p:txBody>
+          <a:bodyPr wrap="square">
+            <a:spAutoFit/>
+          </a:bodyPr>
+          <a:lstStyle/>
+          <a:p>
+            <a:pPr algn="l"/>
+            <a:r>
+              <a:rPr sz="1200" b="0">
+                <a:solidFill>
+                  <a:srgbClr val="333333"/>
+                </a:solidFill>
+              </a:rPr>
+              <a:t>✔  Architectural consistency with FTP —
+    all four primary protocol clients now
+    follow the same two-tier Facade contract
+✔  Single source of truth for raw I/O —
+    every dot-terminated reader and writer is
+    constructed in exactly one place per protocol
+✔  No public API breakage — every modified
+    method keeps the same signature, return
+    contract, and observable behavior
+✔  Additive — new base-class methods are
+    inherited automatically by SMTPSClient,
+    IMAPSClient, NNTPSClient, AuthenticatingSMTPClient,
+    and AuthenticatingIMAPClient with no further work</a:t>
+            </a:r>
+          </a:p>
+        </p:txBody>
+      </p:sp>
+      <p:sp>
+        <p:nvSpPr>
+          <p:cNvPr id="8" name="Rectangle 7"/>
+          <p:cNvSpPr/>
+          <p:nvPr/>
+        </p:nvSpPr>
+        <p:spPr>
+          <a:xfrm>
+            <a:off x="5852160" y="1234440"/>
+            <a:ext cx="6035040" cy="2651760"/>
+          </a:xfrm>
+          <a:prstGeom prst="rect">
+            <a:avLst/>
+          </a:prstGeom>
+          <a:solidFill>
+            <a:srgbClr val="FFE6CC"/>
+          </a:solidFill>
+          <a:ln w="9525">
+            <a:solidFill>
+              <a:srgbClr val="D79B00"/>
+            </a:solidFill>
+          </a:ln>
+        </p:spPr>
+        <p:style>
+          <a:lnRef idx="1">
+            <a:schemeClr val="accent1"/>
+          </a:lnRef>
+          <a:fillRef idx="3">
+            <a:schemeClr val="accent1"/>
+          </a:fillRef>
+          <a:effectRef idx="2">
+            <a:schemeClr val="accent1"/>
+          </a:effectRef>
+          <a:fontRef idx="minor">
+            <a:schemeClr val="lt1"/>
+          </a:fontRef>
+        </p:style>
+        <p:txBody>
+          <a:bodyPr rtlCol="0" anchor="ctr"/>
+          <a:lstStyle/>
+          <a:p>
+            <a:pPr algn="ctr"/>
+          </a:p>
+        </p:txBody>
+      </p:sp>
+      <p:sp>
+        <p:nvSpPr>
+          <p:cNvPr id="9" name="TextBox 8"/>
+          <p:cNvSpPr txBox="1"/>
+          <p:nvPr/>
+        </p:nvSpPr>
+        <p:spPr>
+          <a:xfrm>
+            <a:off x="5989320" y="1298448"/>
+            <a:ext cx="5760720" cy="320040"/>
+          </a:xfrm>
+          <a:prstGeom prst="rect">
+            <a:avLst/>
+          </a:prstGeom>
+          <a:noFill/>
+        </p:spPr>
+        <p:txBody>
+          <a:bodyPr wrap="square">
+            <a:spAutoFit/>
+          </a:bodyPr>
+          <a:lstStyle/>
+          <a:p>
+            <a:pPr algn="l"/>
+            <a:r>
+              <a:rPr sz="1400" b="1">
+                <a:solidFill>
+                  <a:srgbClr val="D79B00"/>
+                </a:solidFill>
+              </a:rPr>
+              <a:t>Cons</a:t>
+            </a:r>
+          </a:p>
+        </p:txBody>
+      </p:sp>
+      <p:sp>
+        <p:nvSpPr>
+          <p:cNvPr id="10" name="TextBox 9"/>
+          <p:cNvSpPr txBox="1"/>
+          <p:nvPr/>
+        </p:nvSpPr>
+        <p:spPr>
+          <a:xfrm>
+            <a:off x="5989320" y="1664208"/>
+            <a:ext cx="5760720" cy="2103120"/>
+          </a:xfrm>
+          <a:prstGeom prst="rect">
+            <a:avLst/>
+          </a:prstGeom>
+          <a:noFill/>
+        </p:spPr>
+        <p:txBody>
+          <a:bodyPr wrap="square">
+            <a:spAutoFit/>
+          </a:bodyPr>
+          <a:lstStyle/>
+          <a:p>
+            <a:pPr algn="l"/>
+            <a:r>
+              <a:rPr sz="1200" b="0">
+                <a:solidFill>
+                  <a:srgbClr val="333333"/>
+                </a:solidFill>
+              </a:rPr>
+              <a:t>✖  Three base classes were modified —
+    additions are small but the change is not
+    confined to one file
+✖  Some private NNTPClient parsing helpers
+    still construct DotTerminatedMessageReader
+    inline — intentionally left for the upcoming
+    Factory + Strategy parser refactor to avoid
+    a merge conflict
+✖  No new user-visible feature — the benefit
+    is design clarity and maintainability, not
+    new capability that callers can invoke</a:t>
+            </a:r>
+          </a:p>
+        </p:txBody>
+      </p:sp>
+      <p:sp>
+        <p:nvSpPr>
+          <p:cNvPr id="11" name="Rectangle 10"/>
+          <p:cNvSpPr/>
+          <p:nvPr/>
+        </p:nvSpPr>
+        <p:spPr>
+          <a:xfrm>
+            <a:off x="274320" y="4069080"/>
+            <a:ext cx="11612880" cy="2377440"/>
+          </a:xfrm>
+          <a:prstGeom prst="rect">
+            <a:avLst/>
+          </a:prstGeom>
+          <a:solidFill>
+            <a:srgbClr val="DAE8FC"/>
+          </a:solidFill>
+          <a:ln w="9525">
+            <a:solidFill>
+              <a:srgbClr val="1F3D6B"/>
+            </a:solidFill>
+          </a:ln>
+        </p:spPr>
+        <p:style>
+          <a:lnRef idx="1">
+            <a:schemeClr val="accent1"/>
+          </a:lnRef>
+          <a:fillRef idx="3">
+            <a:schemeClr val="accent1"/>
+          </a:fillRef>
+          <a:effectRef idx="2">
+            <a:schemeClr val="accent1"/>
+          </a:effectRef>
+          <a:fontRef idx="minor">
+            <a:schemeClr val="lt1"/>
+          </a:fontRef>
+        </p:style>
+        <p:txBody>
+          <a:bodyPr rtlCol="0" anchor="ctr"/>
+          <a:lstStyle/>
+          <a:p>
+            <a:pPr algn="ctr"/>
+          </a:p>
+        </p:txBody>
+      </p:sp>
+      <p:sp>
+        <p:nvSpPr>
+          <p:cNvPr id="12" name="TextBox 11"/>
+          <p:cNvSpPr txBox="1"/>
+          <p:nvPr/>
+        </p:nvSpPr>
+        <p:spPr>
+          <a:xfrm>
+            <a:off x="411480" y="4133087"/>
+            <a:ext cx="5486400" cy="320040"/>
+          </a:xfrm>
+          <a:prstGeom prst="rect">
+            <a:avLst/>
+          </a:prstGeom>
+          <a:noFill/>
+        </p:spPr>
+        <p:txBody>
+          <a:bodyPr wrap="square">
+            <a:spAutoFit/>
+          </a:bodyPr>
+          <a:lstStyle/>
+          <a:p>
+            <a:pPr algn="l"/>
+            <a:r>
+              <a:rPr sz="1400" b="1">
+                <a:solidFill>
+                  <a:srgbClr val="1F3D6B"/>
+                </a:solidFill>
+              </a:rPr>
+              <a:t>Implementation</a:t>
+            </a:r>
+          </a:p>
+        </p:txBody>
+      </p:sp>
+      <p:sp>
+        <p:nvSpPr>
+          <p:cNvPr id="13" name="TextBox 12"/>
+          <p:cNvSpPr txBox="1"/>
+          <p:nvPr/>
+        </p:nvSpPr>
+        <p:spPr>
+          <a:xfrm>
+            <a:off x="411480" y="4498848"/>
+            <a:ext cx="11064240" cy="1828800"/>
+          </a:xfrm>
+          <a:prstGeom prst="rect">
+            <a:avLst/>
+          </a:prstGeom>
+          <a:noFill/>
+        </p:spPr>
+        <p:txBody>
+          <a:bodyPr wrap="square">
+            <a:spAutoFit/>
+          </a:bodyPr>
+          <a:lstStyle/>
+          <a:p>
+            <a:pPr algn="l"/>
+            <a:r>
+              <a:rPr sz="1100" b="0">
+                <a:solidFill>
+                  <a:srgbClr val="333333"/>
+                </a:solidFill>
+              </a:rPr>
+              <a:t>SMTP.java — added imports for java.io.Writer and DotTerminatedMessageWriter; added protected Writer getDataWriter() that wraps _writer
+SMTPClient.java — sendMessageData() now calls getDataWriter(); removed the now-unused DotTerminatedMessageWriter import
+IMAP.java — added public boolean appendWithData(String args, String message) that performs the full two-step APPEND wire exchange
+IMAPClient.java — append() now delegates the continuation+literal protocol to appendWithData()
+NNTP.java — added imports for Writer, DotTerminatedMessageReader, DotTerminatedMessageWriter; added protected BufferedReader openMessageReader() and protected Writer getDataWriter()
+NNTPClient.java — __retrieve() overloads return openMessageReader(); postArticle() and forwardArticle() return getDataWriter(); private parsing helpers untouched (scoped to the parser refactor)
+No code already finalized for Problem 1 (enums), Part 1 Problem 2 (Observer firing), Part 1 Problem 5 (SSL), Builder, or Singleton was modified</a:t>
             </a:r>
           </a:p>
         </p:txBody>

</xml_diff>